<commit_message>
Replace October spend trend with month-to-date figure in designed deck
Co-Authored-By: Claude Opus 5.5 <noreply@anthropic.com>
Claude-Session: https://claude.ai/code/session_01QGMjcfWM6zwQECSVCibDW3
</commit_message>
<xml_diff>
--- a/status_ceo/Stormberg Foods_Update October 1-13th_corregido.pptx
+++ b/status_ceo/Stormberg Foods_Update October 1-13th_corregido.pptx
@@ -1713,7 +1713,7 @@
                 <a:cs typeface="Calibri"/>
                 <a:sym typeface="Calibri"/>
               </a:rPr>
-              <a:t>First, how we work: we don't stop at what an AI tool says; we go into the dashboard and each platform to understand what drives every number. From that, there's one message per brand. Brooklyn: we held the margin while cutting investment by about 40%, and now the challenge is growing sales. Beg &amp; Barker: it's efficient, but competing in search is very hard, so we're shifting focus to new customers with promos and to Amazon. Ayoba: traffic is good, but the website converts poorly, so we propose testing toward Amazon.</a:t>
+              <a:t>First, how we work: we don't stop at what an AI tool says; we go into the dashboard and each platform to understand what drives every number. From that, there's one message per brand. Brooklyn: we held the margin while cutting investment 35% from May to September, and now the challenge is growing sales. Beg &amp; Barker: it's efficient, but competing in search is very hard, so we're shifting focus to new customers with promos and to Amazon. Ayoba: traffic is good, but the website converts poorly, so we propose testing toward Amazon.</a:t>
             </a:r>
             <a:endParaRPr/>
           </a:p>
@@ -2065,7 +2065,7 @@
                 <a:cs typeface="Calibri"/>
                 <a:sym typeface="Calibri"/>
               </a:rPr>
-              <a:t>The key point: we cut investment from $11K in May to $7.1K in September and a $6.3K trend in October, and the margin held at around 20%. Subscriptions and value per purchase went up. Conversion fell from 2.54% to 2.16% because of a campaign optimized for traffic, and sessions outside social dropped 11%. New customers went from 84 to 75, so acquisition is the next push. Meta retargeting does what it should, with an indirect lift on the other campaigns. In email we'll send more, more focused messages. The next step is growing sales, and it starts tomorrow with the Fast Sale.</a:t>
+              <a:t>The key point: we cut investment from $11K in May to $7.1K in September, and the margin held at around 20%. In October we have invested $3.2K through the 13th: we are holding investment and shifting it toward Meta to grow sales. Subscriptions and value per purchase went up. Conversion fell from 2.54% to 2.16% because of a campaign optimized for traffic, and sessions outside social dropped 11%. New customers went from 84 to 75, so acquisition is the next push. Meta retargeting does what it should, with an indirect lift on the other campaigns. In email we'll send more, more focused messages. The next step is growing sales, and it starts tomorrow with the Fast Sale.</a:t>
             </a:r>
             <a:endParaRPr/>
           </a:p>
@@ -13651,7 +13651,7 @@
                 <a:cs typeface="Arial Black"/>
                 <a:sym typeface="Arial Black"/>
               </a:rPr>
-              <a:t>$11K → $6.3K</a:t>
+              <a:t>$11K → $7.1K</a:t>
             </a:r>
             <a:endParaRPr sz="7200">
               <a:solidFill>
@@ -13777,7 +13777,7 @@
                 <a:cs typeface="Archivo"/>
                 <a:sym typeface="Archivo"/>
               </a:rPr>
-              <a:t>May vs. Oct, steady margin</a:t>
+              <a:t>May vs. Sep, steady margin</a:t>
             </a:r>
             <a:endParaRPr sz="1800">
               <a:solidFill>
@@ -14222,7 +14222,7 @@
                 <a:cs typeface="Archivo"/>
                 <a:sym typeface="Archivo"/>
               </a:rPr>
-              <a:t>We cut investment by about 40% and the margin held. Now the focus is sales growth, starting with tomorrow's Fast Sale.</a:t>
+              <a:t>We cut investment 35% from May to September and the margin held. Now the focus is sales growth, starting with tomorrow's Fast Sale.</a:t>
             </a:r>
             <a:endParaRPr sz="1875">
               <a:solidFill>
@@ -17322,7 +17322,7 @@
                 <a:cs typeface="Archivo"/>
                 <a:sym typeface="Archivo"/>
               </a:rPr>
-              <a:t>in steady monthly profit since May, on about 40% less media investment</a:t>
+              <a:t>in steady monthly profit since May, on 35% less media investment than May</a:t>
             </a:r>
             <a:endParaRPr sz="1800">
               <a:solidFill>
@@ -18614,7 +18614,7 @@
         </p:nvSpPr>
         <p:spPr>
           <a:xfrm>
-            <a:off x="5991490" y="6253692"/>
+            <a:off x="5991490" y="7036868"/>
             <a:ext cx="1123421" cy="495300"/>
           </a:xfrm>
           <a:prstGeom prst="rect">
@@ -18655,7 +18655,7 @@
                 <a:cs typeface="Bricolage Grotesque"/>
                 <a:sym typeface="Bricolage Grotesque"/>
               </a:rPr>
-              <a:t>$6.3K</a:t>
+              <a:t>$3.2K</a:t>
             </a:r>
             <a:endParaRPr sz="3000">
               <a:solidFill>
@@ -18677,8 +18677,8 @@
         </p:nvSpPr>
         <p:spPr>
           <a:xfrm>
-            <a:off x="5676900" y="6825192"/>
-            <a:ext cx="1676400" cy="1571625"/>
+            <a:off x="5676900" y="7608368"/>
+            <a:ext cx="1676400" cy="788449"/>
           </a:xfrm>
           <a:custGeom>
             <a:rect b="b" l="l" r="r" t="t"/>
@@ -18922,7 +18922,7 @@
                 <a:cs typeface="Archivo"/>
                 <a:sym typeface="Archivo"/>
               </a:rPr>
-              <a:t>October</a:t>
+              <a:t>Oct 1–13</a:t>
             </a:r>
             <a:endParaRPr sz="1800">
               <a:solidFill>

</xml_diff>